<commit_message>
Redesign result figures: success-first, slide-fill, stats corner
Switches the x-axis order on RQ1/RQ2 figures so Success sits on the
left and Failure on the right (matches the talk's narrative beat:
"men get updated more on success — and the same on failure"). Drops
the in-figure title/subtitle/caption/n labels in favor of a small
top-right stats corner on the slide that carries the deltas, b, and
p-value. Bars and axis text are larger; the figure renders at 15x6"
to fill the available slide space.

RQ2 strong/weak slides also get a small top-middle "endorser
confidence" badge (mirrors the Stage 3 stimuli widget) so the audience
recognizes which strength condition we're showing without a written
subtitle.

Co-Authored-By: Claude Opus 4.6 (1M context) <noreply@anthropic.com>
</commit_message>
<xml_diff>
--- a/docs/UChicago-0410.pptx
+++ b/docs/UChicago-0410.pptx
@@ -10866,8 +10866,8 @@
         </p:nvSpPr>
         <p:spPr>
           <a:xfrm>
-            <a:off x="502920" y="274320"/>
-            <a:ext cx="11185855" cy="731520"/>
+            <a:off x="502920" y="365760"/>
+            <a:ext cx="6583680" cy="640080"/>
           </a:xfrm>
           <a:prstGeom prst="rect">
             <a:avLst/>
@@ -10888,14 +10888,158 @@
                 </a:solidFill>
                 <a:latin typeface="Arial"/>
               </a:rPr>
-              <a:t>RQ1:  Gender × Outcome on trust update</a:t>
+              <a:t>RQ1 — Gender × outcome on trust update</a:t>
+            </a:r>
+          </a:p>
+        </p:txBody>
+      </p:sp>
+      <p:sp>
+        <p:nvSpPr>
+          <p:cNvPr id="3" name="Rounded Rectangle 2"/>
+          <p:cNvSpPr/>
+          <p:nvPr/>
+        </p:nvSpPr>
+        <p:spPr>
+          <a:xfrm>
+            <a:off x="8579815" y="274320"/>
+            <a:ext cx="3200400" cy="1325880"/>
+          </a:xfrm>
+          <a:prstGeom prst="roundRect">
+            <a:avLst>
+              <a:gd name="adj" fmla="val 18000"/>
+            </a:avLst>
+          </a:prstGeom>
+          <a:solidFill>
+            <a:srgbClr val="FAFBFC"/>
+          </a:solidFill>
+          <a:ln w="9525">
+            <a:solidFill>
+              <a:srgbClr val="CBD5E1"/>
+            </a:solidFill>
+          </a:ln>
+        </p:spPr>
+        <p:style>
+          <a:lnRef idx="1">
+            <a:schemeClr val="accent1"/>
+          </a:lnRef>
+          <a:fillRef idx="3">
+            <a:schemeClr val="accent1"/>
+          </a:fillRef>
+          <a:effectRef idx="2">
+            <a:schemeClr val="accent1"/>
+          </a:effectRef>
+          <a:fontRef idx="minor">
+            <a:schemeClr val="lt1"/>
+          </a:fontRef>
+        </p:style>
+        <p:txBody>
+          <a:bodyPr rtlCol="0" anchor="ctr" lIns="182880" rIns="182880" tIns="91440" bIns="91440" wrap="square"/>
+          <a:lstStyle/>
+          <a:p>
+            <a:pPr algn="l">
+              <a:spcAft>
+                <a:spcPts val="200"/>
+              </a:spcAft>
+            </a:pPr>
+            <a:r>
+              <a:rPr sz="1500" b="1">
+                <a:solidFill>
+                  <a:srgbClr val="011F5B"/>
+                </a:solidFill>
+                <a:latin typeface="Arial"/>
+              </a:rPr>
+              <a:t>Δ Male  </a:t>
+            </a:r>
+            <a:r>
+              <a:rPr sz="1700" b="1">
+                <a:solidFill>
+                  <a:srgbClr val="011F5B"/>
+                </a:solidFill>
+                <a:latin typeface="Arial"/>
+              </a:rPr>
+              <a:t>+15.0</a:t>
+            </a:r>
+          </a:p>
+          <a:p>
+            <a:pPr algn="l">
+              <a:spcAft>
+                <a:spcPts val="200"/>
+              </a:spcAft>
+            </a:pPr>
+            <a:r>
+              <a:rPr sz="1500" b="1">
+                <a:solidFill>
+                  <a:srgbClr val="990000"/>
+                </a:solidFill>
+                <a:latin typeface="Arial"/>
+              </a:rPr>
+              <a:t>Δ Female  </a:t>
+            </a:r>
+            <a:r>
+              <a:rPr sz="1700" b="1">
+                <a:solidFill>
+                  <a:srgbClr val="990000"/>
+                </a:solidFill>
+                <a:latin typeface="Arial"/>
+              </a:rPr>
+              <a:t>+4.3</a:t>
+            </a:r>
+          </a:p>
+          <a:p>
+            <a:pPr algn="l">
+              <a:spcAft>
+                <a:spcPts val="200"/>
+              </a:spcAft>
+            </a:pPr>
+            <a:r>
+              <a:rPr sz="1300" b="0">
+                <a:solidFill>
+                  <a:srgbClr val="111827"/>
+                </a:solidFill>
+                <a:latin typeface="Arial"/>
+              </a:rPr>
+              <a:t>b  </a:t>
+            </a:r>
+            <a:r>
+              <a:rPr sz="1400" b="1">
+                <a:solidFill>
+                  <a:srgbClr val="111827"/>
+                </a:solidFill>
+                <a:latin typeface="Arial"/>
+              </a:rPr>
+              <a:t>-11.60</a:t>
+            </a:r>
+          </a:p>
+          <a:p>
+            <a:pPr algn="l">
+              <a:spcAft>
+                <a:spcPts val="200"/>
+              </a:spcAft>
+            </a:pPr>
+            <a:r>
+              <a:rPr sz="1300" b="0">
+                <a:solidFill>
+                  <a:srgbClr val="111827"/>
+                </a:solidFill>
+                <a:latin typeface="Arial"/>
+              </a:rPr>
+              <a:t>p  </a:t>
+            </a:r>
+            <a:r>
+              <a:rPr sz="1400" b="1">
+                <a:solidFill>
+                  <a:srgbClr val="111827"/>
+                </a:solidFill>
+                <a:latin typeface="Arial"/>
+              </a:rPr>
+              <a:t>= .062</a:t>
             </a:r>
           </a:p>
         </p:txBody>
       </p:sp>
       <p:pic>
         <p:nvPicPr>
-          <p:cNvPr id="3" name="Picture 2" descr="rq1_gender_x_outcome.png"/>
+          <p:cNvPr id="4" name="Picture 3" descr="rq1_gender_x_outcome.png"/>
           <p:cNvPicPr>
             <a:picLocks noChangeAspect="1"/>
           </p:cNvPicPr>
@@ -10909,8 +11053,8 @@
         </p:blipFill>
         <p:spPr>
           <a:xfrm>
-            <a:off x="1415262" y="1097280"/>
-            <a:ext cx="9361170" cy="5349240"/>
+            <a:off x="95097" y="1645920"/>
+            <a:ext cx="12001500" cy="4800600"/>
           </a:xfrm>
           <a:prstGeom prst="rect">
             <a:avLst/>
@@ -10919,7 +11063,7 @@
       </p:pic>
       <p:sp>
         <p:nvSpPr>
-          <p:cNvPr id="4" name="TextBox 3"/>
+          <p:cNvPr id="5" name="TextBox 4"/>
           <p:cNvSpPr txBox="1"/>
           <p:nvPr/>
         </p:nvSpPr>
@@ -10978,8 +11122,8 @@
         </p:nvSpPr>
         <p:spPr>
           <a:xfrm>
-            <a:off x="502920" y="274320"/>
-            <a:ext cx="11185855" cy="731520"/>
+            <a:off x="502920" y="365760"/>
+            <a:ext cx="6583680" cy="640080"/>
           </a:xfrm>
           <a:prstGeom prst="rect">
             <a:avLst/>
@@ -11000,21 +11144,66 @@
                 </a:solidFill>
                 <a:latin typeface="Arial"/>
               </a:rPr>
-              <a:t>RQ2:  Strong endorsers</a:t>
-            </a:r>
-          </a:p>
-        </p:txBody>
-      </p:sp>
-      <p:sp>
-        <p:nvSpPr>
-          <p:cNvPr id="3" name="TextBox 2"/>
+              <a:t>RQ2 — Strong endorsers</a:t>
+            </a:r>
+          </a:p>
+        </p:txBody>
+      </p:sp>
+      <p:sp>
+        <p:nvSpPr>
+          <p:cNvPr id="3" name="Rounded Rectangle 2"/>
+          <p:cNvSpPr/>
+          <p:nvPr/>
+        </p:nvSpPr>
+        <p:spPr>
+          <a:xfrm>
+            <a:off x="7223760" y="274320"/>
+            <a:ext cx="2194560" cy="1325880"/>
+          </a:xfrm>
+          <a:prstGeom prst="roundRect">
+            <a:avLst>
+              <a:gd name="adj" fmla="val 18000"/>
+            </a:avLst>
+          </a:prstGeom>
+          <a:solidFill>
+            <a:srgbClr val="FAFBFC"/>
+          </a:solidFill>
+          <a:ln w="9525">
+            <a:solidFill>
+              <a:srgbClr val="CBD5E1"/>
+            </a:solidFill>
+          </a:ln>
+        </p:spPr>
+        <p:style>
+          <a:lnRef idx="1">
+            <a:schemeClr val="accent1"/>
+          </a:lnRef>
+          <a:fillRef idx="3">
+            <a:schemeClr val="accent1"/>
+          </a:fillRef>
+          <a:effectRef idx="2">
+            <a:schemeClr val="accent1"/>
+          </a:effectRef>
+          <a:fontRef idx="minor">
+            <a:schemeClr val="lt1"/>
+          </a:fontRef>
+        </p:style>
+        <p:txBody>
+          <a:bodyPr rtlCol="0" anchor="ctr"/>
+          <a:lstStyle/>
+          <a:p/>
+        </p:txBody>
+      </p:sp>
+      <p:sp>
+        <p:nvSpPr>
+          <p:cNvPr id="4" name="TextBox 3"/>
           <p:cNvSpPr txBox="1"/>
           <p:nvPr/>
         </p:nvSpPr>
         <p:spPr>
           <a:xfrm>
-            <a:off x="502920" y="841248"/>
-            <a:ext cx="11247120" cy="384048"/>
+            <a:off x="7388352" y="365760"/>
+            <a:ext cx="1865376" cy="274320"/>
           </a:xfrm>
           <a:prstGeom prst="rect">
             <a:avLst/>
@@ -11029,20 +11218,324 @@
           <a:p>
             <a:pPr algn="l"/>
             <a:r>
-              <a:rPr sz="1400" b="0" i="1">
+              <a:rPr sz="1000" b="1" i="0">
                 <a:solidFill>
                   <a:srgbClr val="6B7280"/>
                 </a:solidFill>
                 <a:latin typeface="Arial"/>
               </a:rPr>
-              <a:t>When sponsors are very confident, the gender × outcome gap is biggest.</a:t>
+              <a:t>ENDORSER CONFIDENCE</a:t>
+            </a:r>
+          </a:p>
+        </p:txBody>
+      </p:sp>
+      <p:sp>
+        <p:nvSpPr>
+          <p:cNvPr id="5" name="Rounded Rectangle 4"/>
+          <p:cNvSpPr/>
+          <p:nvPr/>
+        </p:nvSpPr>
+        <p:spPr>
+          <a:xfrm>
+            <a:off x="7388352" y="777240"/>
+            <a:ext cx="1865376" cy="182880"/>
+          </a:xfrm>
+          <a:prstGeom prst="roundRect">
+            <a:avLst>
+              <a:gd name="adj" fmla="val 50000"/>
+            </a:avLst>
+          </a:prstGeom>
+          <a:solidFill>
+            <a:srgbClr val="E5E7EB"/>
+          </a:solidFill>
+          <a:ln>
+            <a:noFill/>
+          </a:ln>
+        </p:spPr>
+        <p:style>
+          <a:lnRef idx="1">
+            <a:schemeClr val="accent1"/>
+          </a:lnRef>
+          <a:fillRef idx="3">
+            <a:schemeClr val="accent1"/>
+          </a:fillRef>
+          <a:effectRef idx="2">
+            <a:schemeClr val="accent1"/>
+          </a:effectRef>
+          <a:fontRef idx="minor">
+            <a:schemeClr val="lt1"/>
+          </a:fontRef>
+        </p:style>
+        <p:txBody>
+          <a:bodyPr rtlCol="0" anchor="ctr"/>
+          <a:lstStyle/>
+          <a:p>
+            <a:pPr algn="ctr"/>
+          </a:p>
+        </p:txBody>
+      </p:sp>
+      <p:sp>
+        <p:nvSpPr>
+          <p:cNvPr id="6" name="Rounded Rectangle 5"/>
+          <p:cNvSpPr/>
+          <p:nvPr/>
+        </p:nvSpPr>
+        <p:spPr>
+          <a:xfrm>
+            <a:off x="7388352" y="777240"/>
+            <a:ext cx="1585569" cy="182880"/>
+          </a:xfrm>
+          <a:prstGeom prst="roundRect">
+            <a:avLst>
+              <a:gd name="adj" fmla="val 50000"/>
+            </a:avLst>
+          </a:prstGeom>
+          <a:solidFill>
+            <a:srgbClr val="2563EB"/>
+          </a:solidFill>
+          <a:ln>
+            <a:noFill/>
+          </a:ln>
+        </p:spPr>
+        <p:style>
+          <a:lnRef idx="1">
+            <a:schemeClr val="accent1"/>
+          </a:lnRef>
+          <a:fillRef idx="3">
+            <a:schemeClr val="accent1"/>
+          </a:fillRef>
+          <a:effectRef idx="2">
+            <a:schemeClr val="accent1"/>
+          </a:effectRef>
+          <a:fontRef idx="minor">
+            <a:schemeClr val="lt1"/>
+          </a:fontRef>
+        </p:style>
+        <p:txBody>
+          <a:bodyPr rtlCol="0" anchor="ctr"/>
+          <a:lstStyle/>
+          <a:p>
+            <a:pPr algn="ctr"/>
+          </a:p>
+        </p:txBody>
+      </p:sp>
+      <p:sp>
+        <p:nvSpPr>
+          <p:cNvPr id="7" name="TextBox 6"/>
+          <p:cNvSpPr txBox="1"/>
+          <p:nvPr/>
+        </p:nvSpPr>
+        <p:spPr>
+          <a:xfrm>
+            <a:off x="7388352" y="1060704"/>
+            <a:ext cx="1865376" cy="329184"/>
+          </a:xfrm>
+          <a:prstGeom prst="rect">
+            <a:avLst/>
+          </a:prstGeom>
+          <a:noFill/>
+        </p:spPr>
+        <p:txBody>
+          <a:bodyPr wrap="square" anchor="t" lIns="0" rIns="0" tIns="0" bIns="0">
+            <a:spAutoFit/>
+          </a:bodyPr>
+          <a:lstStyle/>
+          <a:p>
+            <a:pPr algn="l"/>
+            <a:r>
+              <a:rPr sz="1800" b="1" i="0">
+                <a:solidFill>
+                  <a:srgbClr val="011F5B"/>
+                </a:solidFill>
+                <a:latin typeface="Arial"/>
+              </a:rPr>
+              <a:t>Strong</a:t>
+            </a:r>
+          </a:p>
+        </p:txBody>
+      </p:sp>
+      <p:sp>
+        <p:nvSpPr>
+          <p:cNvPr id="8" name="TextBox 7"/>
+          <p:cNvSpPr txBox="1"/>
+          <p:nvPr/>
+        </p:nvSpPr>
+        <p:spPr>
+          <a:xfrm>
+            <a:off x="7388352" y="1353312"/>
+            <a:ext cx="1865376" cy="228600"/>
+          </a:xfrm>
+          <a:prstGeom prst="rect">
+            <a:avLst/>
+          </a:prstGeom>
+          <a:noFill/>
+        </p:spPr>
+        <p:txBody>
+          <a:bodyPr wrap="square" anchor="t" lIns="0" rIns="0" tIns="0" bIns="0">
+            <a:spAutoFit/>
+          </a:bodyPr>
+          <a:lstStyle/>
+          <a:p>
+            <a:pPr algn="l"/>
+            <a:r>
+              <a:rPr sz="1100" b="0" i="1">
+                <a:solidFill>
+                  <a:srgbClr val="6B7280"/>
+                </a:solidFill>
+                <a:latin typeface="Arial"/>
+              </a:rPr>
+              <a:t>very confident</a:t>
+            </a:r>
+          </a:p>
+        </p:txBody>
+      </p:sp>
+      <p:sp>
+        <p:nvSpPr>
+          <p:cNvPr id="9" name="Rounded Rectangle 8"/>
+          <p:cNvSpPr/>
+          <p:nvPr/>
+        </p:nvSpPr>
+        <p:spPr>
+          <a:xfrm>
+            <a:off x="8579815" y="274320"/>
+            <a:ext cx="3200400" cy="1325880"/>
+          </a:xfrm>
+          <a:prstGeom prst="roundRect">
+            <a:avLst>
+              <a:gd name="adj" fmla="val 18000"/>
+            </a:avLst>
+          </a:prstGeom>
+          <a:solidFill>
+            <a:srgbClr val="FAFBFC"/>
+          </a:solidFill>
+          <a:ln w="9525">
+            <a:solidFill>
+              <a:srgbClr val="CBD5E1"/>
+            </a:solidFill>
+          </a:ln>
+        </p:spPr>
+        <p:style>
+          <a:lnRef idx="1">
+            <a:schemeClr val="accent1"/>
+          </a:lnRef>
+          <a:fillRef idx="3">
+            <a:schemeClr val="accent1"/>
+          </a:fillRef>
+          <a:effectRef idx="2">
+            <a:schemeClr val="accent1"/>
+          </a:effectRef>
+          <a:fontRef idx="minor">
+            <a:schemeClr val="lt1"/>
+          </a:fontRef>
+        </p:style>
+        <p:txBody>
+          <a:bodyPr rtlCol="0" anchor="ctr" lIns="182880" rIns="182880" tIns="91440" bIns="91440" wrap="square"/>
+          <a:lstStyle/>
+          <a:p>
+            <a:pPr algn="l">
+              <a:spcAft>
+                <a:spcPts val="200"/>
+              </a:spcAft>
+            </a:pPr>
+            <a:r>
+              <a:rPr sz="1500" b="1">
+                <a:solidFill>
+                  <a:srgbClr val="011F5B"/>
+                </a:solidFill>
+                <a:latin typeface="Arial"/>
+              </a:rPr>
+              <a:t>Δ Male  </a:t>
+            </a:r>
+            <a:r>
+              <a:rPr sz="1700" b="1">
+                <a:solidFill>
+                  <a:srgbClr val="011F5B"/>
+                </a:solidFill>
+                <a:latin typeface="Arial"/>
+              </a:rPr>
+              <a:t>+16.8</a:t>
+            </a:r>
+          </a:p>
+          <a:p>
+            <a:pPr algn="l">
+              <a:spcAft>
+                <a:spcPts val="200"/>
+              </a:spcAft>
+            </a:pPr>
+            <a:r>
+              <a:rPr sz="1500" b="1">
+                <a:solidFill>
+                  <a:srgbClr val="990000"/>
+                </a:solidFill>
+                <a:latin typeface="Arial"/>
+              </a:rPr>
+              <a:t>Δ Female  </a:t>
+            </a:r>
+            <a:r>
+              <a:rPr sz="1700" b="1">
+                <a:solidFill>
+                  <a:srgbClr val="990000"/>
+                </a:solidFill>
+                <a:latin typeface="Arial"/>
+              </a:rPr>
+              <a:t>+6.0</a:t>
+            </a:r>
+          </a:p>
+          <a:p>
+            <a:pPr algn="l">
+              <a:spcAft>
+                <a:spcPts val="200"/>
+              </a:spcAft>
+            </a:pPr>
+            <a:r>
+              <a:rPr sz="1300" b="0">
+                <a:solidFill>
+                  <a:srgbClr val="111827"/>
+                </a:solidFill>
+                <a:latin typeface="Arial"/>
+              </a:rPr>
+              <a:t>b  </a:t>
+            </a:r>
+            <a:r>
+              <a:rPr sz="1400" b="1">
+                <a:solidFill>
+                  <a:srgbClr val="111827"/>
+                </a:solidFill>
+                <a:latin typeface="Arial"/>
+              </a:rPr>
+              <a:t>-13.01</a:t>
+            </a:r>
+          </a:p>
+          <a:p>
+            <a:pPr algn="l">
+              <a:spcAft>
+                <a:spcPts val="200"/>
+              </a:spcAft>
+            </a:pPr>
+            <a:r>
+              <a:rPr sz="1300" b="0">
+                <a:solidFill>
+                  <a:srgbClr val="111827"/>
+                </a:solidFill>
+                <a:latin typeface="Arial"/>
+              </a:rPr>
+              <a:t>p  </a:t>
+            </a:r>
+            <a:r>
+              <a:rPr sz="1400" b="1">
+                <a:solidFill>
+                  <a:srgbClr val="111827"/>
+                </a:solidFill>
+                <a:latin typeface="Arial"/>
+              </a:rPr>
+              <a:t>= .113</a:t>
             </a:r>
           </a:p>
         </p:txBody>
       </p:sp>
       <p:pic>
         <p:nvPicPr>
-          <p:cNvPr id="4" name="Picture 3" descr="rq2_strong_only.png"/>
+          <p:cNvPr id="10" name="Picture 9" descr="rq2_strong_only.png"/>
           <p:cNvPicPr>
             <a:picLocks noChangeAspect="1"/>
           </p:cNvPicPr>
@@ -11056,8 +11549,8 @@
         </p:blipFill>
         <p:spPr>
           <a:xfrm>
-            <a:off x="1415262" y="1325880"/>
-            <a:ext cx="9361170" cy="5349240"/>
+            <a:off x="95097" y="1645920"/>
+            <a:ext cx="12001500" cy="4800600"/>
           </a:xfrm>
           <a:prstGeom prst="rect">
             <a:avLst/>
@@ -11066,7 +11559,7 @@
       </p:pic>
       <p:sp>
         <p:nvSpPr>
-          <p:cNvPr id="5" name="TextBox 4"/>
+          <p:cNvPr id="11" name="TextBox 10"/>
           <p:cNvSpPr txBox="1"/>
           <p:nvPr/>
         </p:nvSpPr>
@@ -11125,8 +11618,8 @@
         </p:nvSpPr>
         <p:spPr>
           <a:xfrm>
-            <a:off x="502920" y="274320"/>
-            <a:ext cx="11185855" cy="731520"/>
+            <a:off x="502920" y="365760"/>
+            <a:ext cx="6583680" cy="640080"/>
           </a:xfrm>
           <a:prstGeom prst="rect">
             <a:avLst/>
@@ -11147,21 +11640,66 @@
                 </a:solidFill>
                 <a:latin typeface="Arial"/>
               </a:rPr>
-              <a:t>RQ2:  Weak endorsers</a:t>
-            </a:r>
-          </a:p>
-        </p:txBody>
-      </p:sp>
-      <p:sp>
-        <p:nvSpPr>
-          <p:cNvPr id="3" name="TextBox 2"/>
+              <a:t>RQ2 — Weak endorsers</a:t>
+            </a:r>
+          </a:p>
+        </p:txBody>
+      </p:sp>
+      <p:sp>
+        <p:nvSpPr>
+          <p:cNvPr id="3" name="Rounded Rectangle 2"/>
+          <p:cNvSpPr/>
+          <p:nvPr/>
+        </p:nvSpPr>
+        <p:spPr>
+          <a:xfrm>
+            <a:off x="7223760" y="274320"/>
+            <a:ext cx="2194560" cy="1325880"/>
+          </a:xfrm>
+          <a:prstGeom prst="roundRect">
+            <a:avLst>
+              <a:gd name="adj" fmla="val 18000"/>
+            </a:avLst>
+          </a:prstGeom>
+          <a:solidFill>
+            <a:srgbClr val="FAFBFC"/>
+          </a:solidFill>
+          <a:ln w="9525">
+            <a:solidFill>
+              <a:srgbClr val="CBD5E1"/>
+            </a:solidFill>
+          </a:ln>
+        </p:spPr>
+        <p:style>
+          <a:lnRef idx="1">
+            <a:schemeClr val="accent1"/>
+          </a:lnRef>
+          <a:fillRef idx="3">
+            <a:schemeClr val="accent1"/>
+          </a:fillRef>
+          <a:effectRef idx="2">
+            <a:schemeClr val="accent1"/>
+          </a:effectRef>
+          <a:fontRef idx="minor">
+            <a:schemeClr val="lt1"/>
+          </a:fontRef>
+        </p:style>
+        <p:txBody>
+          <a:bodyPr rtlCol="0" anchor="ctr"/>
+          <a:lstStyle/>
+          <a:p/>
+        </p:txBody>
+      </p:sp>
+      <p:sp>
+        <p:nvSpPr>
+          <p:cNvPr id="4" name="TextBox 3"/>
           <p:cNvSpPr txBox="1"/>
           <p:nvPr/>
         </p:nvSpPr>
         <p:spPr>
           <a:xfrm>
-            <a:off x="502920" y="841248"/>
-            <a:ext cx="11247120" cy="384048"/>
+            <a:off x="7388352" y="365760"/>
+            <a:ext cx="1865376" cy="274320"/>
           </a:xfrm>
           <a:prstGeom prst="rect">
             <a:avLst/>
@@ -11176,20 +11714,324 @@
           <a:p>
             <a:pPr algn="l"/>
             <a:r>
-              <a:rPr sz="1400" b="0" i="1">
+              <a:rPr sz="1000" b="1" i="0">
                 <a:solidFill>
                   <a:srgbClr val="6B7280"/>
                 </a:solidFill>
                 <a:latin typeface="Arial"/>
               </a:rPr>
-              <a:t>When sponsors hedge, the same pattern persists at smaller magnitudes.</a:t>
+              <a:t>ENDORSER CONFIDENCE</a:t>
+            </a:r>
+          </a:p>
+        </p:txBody>
+      </p:sp>
+      <p:sp>
+        <p:nvSpPr>
+          <p:cNvPr id="5" name="Rounded Rectangle 4"/>
+          <p:cNvSpPr/>
+          <p:nvPr/>
+        </p:nvSpPr>
+        <p:spPr>
+          <a:xfrm>
+            <a:off x="7388352" y="777240"/>
+            <a:ext cx="1865376" cy="182880"/>
+          </a:xfrm>
+          <a:prstGeom prst="roundRect">
+            <a:avLst>
+              <a:gd name="adj" fmla="val 50000"/>
+            </a:avLst>
+          </a:prstGeom>
+          <a:solidFill>
+            <a:srgbClr val="E5E7EB"/>
+          </a:solidFill>
+          <a:ln>
+            <a:noFill/>
+          </a:ln>
+        </p:spPr>
+        <p:style>
+          <a:lnRef idx="1">
+            <a:schemeClr val="accent1"/>
+          </a:lnRef>
+          <a:fillRef idx="3">
+            <a:schemeClr val="accent1"/>
+          </a:fillRef>
+          <a:effectRef idx="2">
+            <a:schemeClr val="accent1"/>
+          </a:effectRef>
+          <a:fontRef idx="minor">
+            <a:schemeClr val="lt1"/>
+          </a:fontRef>
+        </p:style>
+        <p:txBody>
+          <a:bodyPr rtlCol="0" anchor="ctr"/>
+          <a:lstStyle/>
+          <a:p>
+            <a:pPr algn="ctr"/>
+          </a:p>
+        </p:txBody>
+      </p:sp>
+      <p:sp>
+        <p:nvSpPr>
+          <p:cNvPr id="6" name="Rounded Rectangle 5"/>
+          <p:cNvSpPr/>
+          <p:nvPr/>
+        </p:nvSpPr>
+        <p:spPr>
+          <a:xfrm>
+            <a:off x="7388352" y="777240"/>
+            <a:ext cx="410382" cy="182880"/>
+          </a:xfrm>
+          <a:prstGeom prst="roundRect">
+            <a:avLst>
+              <a:gd name="adj" fmla="val 50000"/>
+            </a:avLst>
+          </a:prstGeom>
+          <a:solidFill>
+            <a:srgbClr val="2563EB"/>
+          </a:solidFill>
+          <a:ln>
+            <a:noFill/>
+          </a:ln>
+        </p:spPr>
+        <p:style>
+          <a:lnRef idx="1">
+            <a:schemeClr val="accent1"/>
+          </a:lnRef>
+          <a:fillRef idx="3">
+            <a:schemeClr val="accent1"/>
+          </a:fillRef>
+          <a:effectRef idx="2">
+            <a:schemeClr val="accent1"/>
+          </a:effectRef>
+          <a:fontRef idx="minor">
+            <a:schemeClr val="lt1"/>
+          </a:fontRef>
+        </p:style>
+        <p:txBody>
+          <a:bodyPr rtlCol="0" anchor="ctr"/>
+          <a:lstStyle/>
+          <a:p>
+            <a:pPr algn="ctr"/>
+          </a:p>
+        </p:txBody>
+      </p:sp>
+      <p:sp>
+        <p:nvSpPr>
+          <p:cNvPr id="7" name="TextBox 6"/>
+          <p:cNvSpPr txBox="1"/>
+          <p:nvPr/>
+        </p:nvSpPr>
+        <p:spPr>
+          <a:xfrm>
+            <a:off x="7388352" y="1060704"/>
+            <a:ext cx="1865376" cy="329184"/>
+          </a:xfrm>
+          <a:prstGeom prst="rect">
+            <a:avLst/>
+          </a:prstGeom>
+          <a:noFill/>
+        </p:spPr>
+        <p:txBody>
+          <a:bodyPr wrap="square" anchor="t" lIns="0" rIns="0" tIns="0" bIns="0">
+            <a:spAutoFit/>
+          </a:bodyPr>
+          <a:lstStyle/>
+          <a:p>
+            <a:pPr algn="l"/>
+            <a:r>
+              <a:rPr sz="1800" b="1" i="0">
+                <a:solidFill>
+                  <a:srgbClr val="011F5B"/>
+                </a:solidFill>
+                <a:latin typeface="Arial"/>
+              </a:rPr>
+              <a:t>Weak</a:t>
+            </a:r>
+          </a:p>
+        </p:txBody>
+      </p:sp>
+      <p:sp>
+        <p:nvSpPr>
+          <p:cNvPr id="8" name="TextBox 7"/>
+          <p:cNvSpPr txBox="1"/>
+          <p:nvPr/>
+        </p:nvSpPr>
+        <p:spPr>
+          <a:xfrm>
+            <a:off x="7388352" y="1353312"/>
+            <a:ext cx="1865376" cy="228600"/>
+          </a:xfrm>
+          <a:prstGeom prst="rect">
+            <a:avLst/>
+          </a:prstGeom>
+          <a:noFill/>
+        </p:spPr>
+        <p:txBody>
+          <a:bodyPr wrap="square" anchor="t" lIns="0" rIns="0" tIns="0" bIns="0">
+            <a:spAutoFit/>
+          </a:bodyPr>
+          <a:lstStyle/>
+          <a:p>
+            <a:pPr algn="l"/>
+            <a:r>
+              <a:rPr sz="1100" b="0" i="1">
+                <a:solidFill>
+                  <a:srgbClr val="6B7280"/>
+                </a:solidFill>
+                <a:latin typeface="Arial"/>
+              </a:rPr>
+              <a:t>hedged / unsure</a:t>
+            </a:r>
+          </a:p>
+        </p:txBody>
+      </p:sp>
+      <p:sp>
+        <p:nvSpPr>
+          <p:cNvPr id="9" name="Rounded Rectangle 8"/>
+          <p:cNvSpPr/>
+          <p:nvPr/>
+        </p:nvSpPr>
+        <p:spPr>
+          <a:xfrm>
+            <a:off x="8579815" y="274320"/>
+            <a:ext cx="3200400" cy="1325880"/>
+          </a:xfrm>
+          <a:prstGeom prst="roundRect">
+            <a:avLst>
+              <a:gd name="adj" fmla="val 18000"/>
+            </a:avLst>
+          </a:prstGeom>
+          <a:solidFill>
+            <a:srgbClr val="FAFBFC"/>
+          </a:solidFill>
+          <a:ln w="9525">
+            <a:solidFill>
+              <a:srgbClr val="CBD5E1"/>
+            </a:solidFill>
+          </a:ln>
+        </p:spPr>
+        <p:style>
+          <a:lnRef idx="1">
+            <a:schemeClr val="accent1"/>
+          </a:lnRef>
+          <a:fillRef idx="3">
+            <a:schemeClr val="accent1"/>
+          </a:fillRef>
+          <a:effectRef idx="2">
+            <a:schemeClr val="accent1"/>
+          </a:effectRef>
+          <a:fontRef idx="minor">
+            <a:schemeClr val="lt1"/>
+          </a:fontRef>
+        </p:style>
+        <p:txBody>
+          <a:bodyPr rtlCol="0" anchor="ctr" lIns="182880" rIns="182880" tIns="91440" bIns="91440" wrap="square"/>
+          <a:lstStyle/>
+          <a:p>
+            <a:pPr algn="l">
+              <a:spcAft>
+                <a:spcPts val="200"/>
+              </a:spcAft>
+            </a:pPr>
+            <a:r>
+              <a:rPr sz="1500" b="1">
+                <a:solidFill>
+                  <a:srgbClr val="011F5B"/>
+                </a:solidFill>
+                <a:latin typeface="Arial"/>
+              </a:rPr>
+              <a:t>Δ Male  </a:t>
+            </a:r>
+            <a:r>
+              <a:rPr sz="1700" b="1">
+                <a:solidFill>
+                  <a:srgbClr val="011F5B"/>
+                </a:solidFill>
+                <a:latin typeface="Arial"/>
+              </a:rPr>
+              <a:t>+12.6</a:t>
+            </a:r>
+          </a:p>
+          <a:p>
+            <a:pPr algn="l">
+              <a:spcAft>
+                <a:spcPts val="200"/>
+              </a:spcAft>
+            </a:pPr>
+            <a:r>
+              <a:rPr sz="1500" b="1">
+                <a:solidFill>
+                  <a:srgbClr val="990000"/>
+                </a:solidFill>
+                <a:latin typeface="Arial"/>
+              </a:rPr>
+              <a:t>Δ Female  </a:t>
+            </a:r>
+            <a:r>
+              <a:rPr sz="1700" b="1">
+                <a:solidFill>
+                  <a:srgbClr val="990000"/>
+                </a:solidFill>
+                <a:latin typeface="Arial"/>
+              </a:rPr>
+              <a:t>+3.4</a:t>
+            </a:r>
+          </a:p>
+          <a:p>
+            <a:pPr algn="l">
+              <a:spcAft>
+                <a:spcPts val="200"/>
+              </a:spcAft>
+            </a:pPr>
+            <a:r>
+              <a:rPr sz="1300" b="0">
+                <a:solidFill>
+                  <a:srgbClr val="111827"/>
+                </a:solidFill>
+                <a:latin typeface="Arial"/>
+              </a:rPr>
+              <a:t>b  </a:t>
+            </a:r>
+            <a:r>
+              <a:rPr sz="1400" b="1">
+                <a:solidFill>
+                  <a:srgbClr val="111827"/>
+                </a:solidFill>
+                <a:latin typeface="Arial"/>
+              </a:rPr>
+              <a:t>-9.50</a:t>
+            </a:r>
+          </a:p>
+          <a:p>
+            <a:pPr algn="l">
+              <a:spcAft>
+                <a:spcPts val="200"/>
+              </a:spcAft>
+            </a:pPr>
+            <a:r>
+              <a:rPr sz="1300" b="0">
+                <a:solidFill>
+                  <a:srgbClr val="111827"/>
+                </a:solidFill>
+                <a:latin typeface="Arial"/>
+              </a:rPr>
+              <a:t>p  </a:t>
+            </a:r>
+            <a:r>
+              <a:rPr sz="1400" b="1">
+                <a:solidFill>
+                  <a:srgbClr val="111827"/>
+                </a:solidFill>
+                <a:latin typeface="Arial"/>
+              </a:rPr>
+              <a:t>= .322</a:t>
             </a:r>
           </a:p>
         </p:txBody>
       </p:sp>
       <p:pic>
         <p:nvPicPr>
-          <p:cNvPr id="4" name="Picture 3" descr="rq2_weak_only.png"/>
+          <p:cNvPr id="10" name="Picture 9" descr="rq2_weak_only.png"/>
           <p:cNvPicPr>
             <a:picLocks noChangeAspect="1"/>
           </p:cNvPicPr>
@@ -11203,8 +12045,8 @@
         </p:blipFill>
         <p:spPr>
           <a:xfrm>
-            <a:off x="1415262" y="1325880"/>
-            <a:ext cx="9361170" cy="5349240"/>
+            <a:off x="95097" y="1645920"/>
+            <a:ext cx="12001500" cy="4800600"/>
           </a:xfrm>
           <a:prstGeom prst="rect">
             <a:avLst/>
@@ -11213,7 +12055,7 @@
       </p:pic>
       <p:sp>
         <p:nvSpPr>
-          <p:cNvPr id="5" name="TextBox 4"/>
+          <p:cNvPr id="11" name="TextBox 10"/>
           <p:cNvSpPr txBox="1"/>
           <p:nvPr/>
         </p:nvSpPr>
@@ -11272,8 +12114,8 @@
         </p:nvSpPr>
         <p:spPr>
           <a:xfrm>
-            <a:off x="502920" y="274320"/>
-            <a:ext cx="11185855" cy="731520"/>
+            <a:off x="502920" y="365760"/>
+            <a:ext cx="6583680" cy="640080"/>
           </a:xfrm>
           <a:prstGeom prst="rect">
             <a:avLst/>
@@ -11294,42 +12136,126 @@
                 </a:solidFill>
                 <a:latin typeface="Arial"/>
               </a:rPr>
-              <a:t>RQ3:  Does the bias exist before any outcome?</a:t>
-            </a:r>
-          </a:p>
-        </p:txBody>
-      </p:sp>
-      <p:sp>
-        <p:nvSpPr>
-          <p:cNvPr id="3" name="TextBox 2"/>
-          <p:cNvSpPr txBox="1"/>
+              <a:t>RQ3 — Pre-outcome trust by gender</a:t>
+            </a:r>
+          </a:p>
+        </p:txBody>
+      </p:sp>
+      <p:sp>
+        <p:nvSpPr>
+          <p:cNvPr id="3" name="Rounded Rectangle 2"/>
+          <p:cNvSpPr/>
           <p:nvPr/>
         </p:nvSpPr>
         <p:spPr>
           <a:xfrm>
-            <a:off x="502920" y="841248"/>
-            <a:ext cx="11247120" cy="384048"/>
-          </a:xfrm>
-          <a:prstGeom prst="rect">
-            <a:avLst/>
-          </a:prstGeom>
-          <a:noFill/>
-        </p:spPr>
-        <p:txBody>
-          <a:bodyPr wrap="square" anchor="t" lIns="0" rIns="0" tIns="0" bIns="0">
-            <a:spAutoFit/>
-          </a:bodyPr>
+            <a:off x="8579815" y="274320"/>
+            <a:ext cx="3200400" cy="1325880"/>
+          </a:xfrm>
+          <a:prstGeom prst="roundRect">
+            <a:avLst>
+              <a:gd name="adj" fmla="val 18000"/>
+            </a:avLst>
+          </a:prstGeom>
+          <a:solidFill>
+            <a:srgbClr val="FAFBFC"/>
+          </a:solidFill>
+          <a:ln w="9525">
+            <a:solidFill>
+              <a:srgbClr val="CBD5E1"/>
+            </a:solidFill>
+          </a:ln>
+        </p:spPr>
+        <p:style>
+          <a:lnRef idx="1">
+            <a:schemeClr val="accent1"/>
+          </a:lnRef>
+          <a:fillRef idx="3">
+            <a:schemeClr val="accent1"/>
+          </a:fillRef>
+          <a:effectRef idx="2">
+            <a:schemeClr val="accent1"/>
+          </a:effectRef>
+          <a:fontRef idx="minor">
+            <a:schemeClr val="lt1"/>
+          </a:fontRef>
+        </p:style>
+        <p:txBody>
+          <a:bodyPr rtlCol="0" anchor="ctr" lIns="182880" rIns="182880" tIns="91440" bIns="91440" wrap="square"/>
           <a:lstStyle/>
           <a:p>
-            <a:pPr algn="l"/>
-            <a:r>
-              <a:rPr sz="1400" b="0" i="1">
+            <a:pPr algn="l">
+              <a:spcAft>
+                <a:spcPts val="200"/>
+              </a:spcAft>
+            </a:pPr>
+            <a:r>
+              <a:rPr sz="1500" b="1">
+                <a:solidFill>
+                  <a:srgbClr val="011F5B"/>
+                </a:solidFill>
+                <a:latin typeface="Arial"/>
+              </a:rPr>
+              <a:t>b gender  </a:t>
+            </a:r>
+            <a:r>
+              <a:rPr sz="1700" b="1">
+                <a:solidFill>
+                  <a:srgbClr val="011F5B"/>
+                </a:solidFill>
+                <a:latin typeface="Arial"/>
+              </a:rPr>
+              <a:t>-1.06</a:t>
+            </a:r>
+          </a:p>
+          <a:p>
+            <a:pPr algn="l">
+              <a:spcAft>
+                <a:spcPts val="200"/>
+              </a:spcAft>
+            </a:pPr>
+            <a:r>
+              <a:rPr sz="1500" b="1">
+                <a:solidFill>
+                  <a:srgbClr val="111827"/>
+                </a:solidFill>
+                <a:latin typeface="Arial"/>
+              </a:rPr>
+              <a:t>p  </a:t>
+            </a:r>
+            <a:r>
+              <a:rPr sz="1700" b="1">
+                <a:solidFill>
+                  <a:srgbClr val="111827"/>
+                </a:solidFill>
+                <a:latin typeface="Arial"/>
+              </a:rPr>
+              <a:t>= .812</a:t>
+            </a:r>
+          </a:p>
+          <a:p>
+            <a:pPr algn="l">
+              <a:spcAft>
+                <a:spcPts val="200"/>
+              </a:spcAft>
+            </a:pPr>
+            <a:r>
+              <a:rPr sz="1300" b="0">
                 <a:solidFill>
                   <a:srgbClr val="6B7280"/>
                 </a:solidFill>
                 <a:latin typeface="Arial"/>
               </a:rPr>
-              <a:t>Before the outcome arrives, audiences trust male and female sponsors equally.</a:t>
+              <a:t>   </a:t>
+            </a:r>
+            <a:r>
+              <a:rPr sz="1400" b="1">
+                <a:solidFill>
+                  <a:srgbClr val="6B7280"/>
+                </a:solidFill>
+                <a:latin typeface="Arial"/>
+              </a:rPr>
+              <a:t>no gender effect</a:t>
             </a:r>
           </a:p>
         </p:txBody>
@@ -11350,8 +12276,8 @@
         </p:blipFill>
         <p:spPr>
           <a:xfrm>
-            <a:off x="1415262" y="1325880"/>
-            <a:ext cx="9361170" cy="5349240"/>
+            <a:off x="975207" y="1645920"/>
+            <a:ext cx="10241280" cy="4800600"/>
           </a:xfrm>
           <a:prstGeom prst="rect">
             <a:avLst/>

</xml_diff>

<commit_message>
Push remaining deck assets and latest manual edits
Bundles the last untracked supporting assets used by the talk pipeline:

  - Updated UChicago-0410.pptx (with the user's most recent manual
    PowerPoint edits since the last commit)
  - Maurice slide image extractions used as inputs to the build pipeline
    (cover, slides 3-6, 8, 21 hires + the per-slide rasters)
  - Stage 3 all-conditions screenshot pool (24 condition screens) and
    the legacy 8-cell design grid composite
  - PDF page extractions kept for reference
  - Refreshed raw_export_fresh.json data export and the live Qualtrics
    survey definition cache

Co-Authored-By: Claude Opus 4.6 (1M context) <noreply@anthropic.com>
</commit_message>
<xml_diff>
--- a/docs/UChicago-0410.pptx
+++ b/docs/UChicago-0410.pptx
@@ -10584,7 +10584,7 @@
             <a:fld id="{DD253308-F9C5-4FCB-8415-6DEE77C16A35}" type="slidenum">
               <a:rPr lang="en-US" smtClean="0"/>
               <a:pPr/>
-              <a:t>10</a:t>
+              <a:t>11</a:t>
             </a:fld>
             <a:endParaRPr lang="en-US" dirty="0"/>
           </a:p>
@@ -10733,7 +10733,7 @@
             <a:fld id="{DD253308-F9C5-4FCB-8415-6DEE77C16A35}" type="slidenum">
               <a:rPr lang="en-US" smtClean="0"/>
               <a:pPr/>
-              <a:t>10</a:t>
+              <a:t>12</a:t>
             </a:fld>
             <a:endParaRPr lang="en-US" dirty="0"/>
           </a:p>
@@ -10882,7 +10882,7 @@
             <a:fld id="{DD253308-F9C5-4FCB-8415-6DEE77C16A35}" type="slidenum">
               <a:rPr lang="en-US" smtClean="0"/>
               <a:pPr/>
-              <a:t>10</a:t>
+              <a:t>13</a:t>
             </a:fld>
             <a:endParaRPr lang="en-US" dirty="0"/>
           </a:p>
@@ -11116,7 +11116,7 @@
             <a:fld id="{DD253308-F9C5-4FCB-8415-6DEE77C16A35}" type="slidenum">
               <a:rPr lang="en-US" smtClean="0"/>
               <a:pPr/>
-              <a:t>10</a:t>
+              <a:t>14</a:t>
             </a:fld>
             <a:endParaRPr lang="en-US" dirty="0"/>
           </a:p>
@@ -11131,7 +11131,7 @@
           <p:nvPr/>
         </p:nvPicPr>
         <p:blipFill>
-          <a:blip r:embed="rId3"/>
+          <a:blip r:embed="rId2"/>
           <a:stretch>
             <a:fillRect/>
           </a:stretch>
@@ -11618,7 +11618,7 @@
             <a:fld id="{DD253308-F9C5-4FCB-8415-6DEE77C16A35}" type="slidenum">
               <a:rPr lang="en-US" smtClean="0"/>
               <a:pPr/>
-              <a:t>10</a:t>
+              <a:t>15</a:t>
             </a:fld>
             <a:endParaRPr lang="en-US" dirty="0"/>
           </a:p>
@@ -11633,7 +11633,7 @@
           <p:nvPr/>
         </p:nvPicPr>
         <p:blipFill>
-          <a:blip r:embed="rId3"/>
+          <a:blip r:embed="rId2"/>
           <a:stretch>
             <a:fillRect/>
           </a:stretch>
@@ -12120,7 +12120,7 @@
             <a:fld id="{DD253308-F9C5-4FCB-8415-6DEE77C16A35}" type="slidenum">
               <a:rPr lang="en-US" smtClean="0"/>
               <a:pPr/>
-              <a:t>10</a:t>
+              <a:t>16</a:t>
             </a:fld>
             <a:endParaRPr lang="en-US" dirty="0"/>
           </a:p>
@@ -12135,7 +12135,7 @@
           <p:nvPr/>
         </p:nvPicPr>
         <p:blipFill>
-          <a:blip r:embed="rId3"/>
+          <a:blip r:embed="rId2"/>
           <a:stretch>
             <a:fillRect/>
           </a:stretch>
@@ -12353,7 +12353,7 @@
             <a:fld id="{DD253308-F9C5-4FCB-8415-6DEE77C16A35}" type="slidenum">
               <a:rPr lang="en-US" smtClean="0"/>
               <a:pPr/>
-              <a:t>10</a:t>
+              <a:t>17</a:t>
             </a:fld>
             <a:endParaRPr lang="en-US" dirty="0"/>
           </a:p>
@@ -12368,7 +12368,7 @@
           <p:nvPr/>
         </p:nvPicPr>
         <p:blipFill>
-          <a:blip r:embed="rId3"/>
+          <a:blip r:embed="rId2"/>
           <a:stretch>
             <a:fillRect/>
           </a:stretch>
@@ -12591,7 +12591,7 @@
             <a:fld id="{DD253308-F9C5-4FCB-8415-6DEE77C16A35}" type="slidenum">
               <a:rPr lang="en-US" smtClean="0"/>
               <a:pPr/>
-              <a:t>10</a:t>
+              <a:t>18</a:t>
             </a:fld>
             <a:endParaRPr lang="en-US" dirty="0"/>
           </a:p>
@@ -12606,7 +12606,7 @@
           <p:nvPr/>
         </p:nvPicPr>
         <p:blipFill>
-          <a:blip r:embed="rId3"/>
+          <a:blip r:embed="rId2"/>
           <a:stretch>
             <a:fillRect/>
           </a:stretch>
@@ -12871,7 +12871,7 @@
             <a:fld id="{DD253308-F9C5-4FCB-8415-6DEE77C16A35}" type="slidenum">
               <a:rPr lang="en-US" smtClean="0"/>
               <a:pPr/>
-              <a:t>10</a:t>
+              <a:t>19</a:t>
             </a:fld>
             <a:endParaRPr lang="en-US" dirty="0"/>
           </a:p>
@@ -13891,7 +13891,7 @@
             <a:fld id="{DD253308-F9C5-4FCB-8415-6DEE77C16A35}" type="slidenum">
               <a:rPr lang="en-US" smtClean="0"/>
               <a:pPr/>
-              <a:t>10</a:t>
+              <a:t>2</a:t>
             </a:fld>
             <a:endParaRPr lang="en-US" dirty="0"/>
           </a:p>
@@ -14592,7 +14592,7 @@
             <a:fld id="{DD253308-F9C5-4FCB-8415-6DEE77C16A35}" type="slidenum">
               <a:rPr lang="en-US" smtClean="0"/>
               <a:pPr/>
-              <a:t>10</a:t>
+              <a:t>20</a:t>
             </a:fld>
             <a:endParaRPr lang="en-US" dirty="0"/>
           </a:p>
@@ -14804,7 +14804,7 @@
             <a:fld id="{DD253308-F9C5-4FCB-8415-6DEE77C16A35}" type="slidenum">
               <a:rPr lang="en-US" smtClean="0"/>
               <a:pPr/>
-              <a:t>10</a:t>
+              <a:t>3</a:t>
             </a:fld>
             <a:endParaRPr lang="en-US" dirty="0"/>
           </a:p>
@@ -15157,7 +15157,7 @@
             <a:fld id="{DD253308-F9C5-4FCB-8415-6DEE77C16A35}" type="slidenum">
               <a:rPr lang="en-US" smtClean="0"/>
               <a:pPr/>
-              <a:t>10</a:t>
+              <a:t>4</a:t>
             </a:fld>
             <a:endParaRPr lang="en-US" dirty="0"/>
           </a:p>
@@ -15522,7 +15522,7 @@
             <a:fld id="{DD253308-F9C5-4FCB-8415-6DEE77C16A35}" type="slidenum">
               <a:rPr lang="en-US" smtClean="0"/>
               <a:pPr/>
-              <a:t>10</a:t>
+              <a:t>5</a:t>
             </a:fld>
             <a:endParaRPr lang="en-US" dirty="0"/>
           </a:p>
@@ -15586,6 +15586,96 @@
                       </p:childTnLst>
                     </p:cTn>
                   </p:par>
+                  <p:par>
+                    <p:cTn id="7" fill="hold">
+                      <p:stCondLst>
+                        <p:cond delay="indefinite"/>
+                      </p:stCondLst>
+                      <p:childTnLst>
+                        <p:par>
+                          <p:cTn id="8" fill="hold">
+                            <p:stCondLst>
+                              <p:cond delay="0"/>
+                            </p:stCondLst>
+                            <p:childTnLst>
+                              <p:par>
+                                <p:cTn id="9" presetID="1" presetClass="entr" presetSubtype="0" fill="hold" grpId="0" nodeType="clickEffect">
+                                  <p:stCondLst>
+                                    <p:cond delay="0"/>
+                                  </p:stCondLst>
+                                  <p:childTnLst>
+                                    <p:set>
+                                      <p:cBhvr>
+                                        <p:cTn id="10" dur="1" fill="hold">
+                                          <p:stCondLst>
+                                            <p:cond delay="0"/>
+                                          </p:stCondLst>
+                                        </p:cTn>
+                                        <p:tgtEl>
+                                          <p:spTgt spid="4"/>
+                                        </p:tgtEl>
+                                        <p:attrNameLst>
+                                          <p:attrName>style.visibility</p:attrName>
+                                        </p:attrNameLst>
+                                      </p:cBhvr>
+                                      <p:to>
+                                        <p:strVal val="visible"/>
+                                      </p:to>
+                                    </p:set>
+                                  </p:childTnLst>
+                                </p:cTn>
+                              </p:par>
+                            </p:childTnLst>
+                          </p:cTn>
+                        </p:par>
+                      </p:childTnLst>
+                    </p:cTn>
+                  </p:par>
+                  <p:par>
+                    <p:cTn id="11" fill="hold">
+                      <p:stCondLst>
+                        <p:cond delay="indefinite"/>
+                      </p:stCondLst>
+                      <p:childTnLst>
+                        <p:par>
+                          <p:cTn id="12" fill="hold">
+                            <p:stCondLst>
+                              <p:cond delay="0"/>
+                            </p:stCondLst>
+                            <p:childTnLst>
+                              <p:par>
+                                <p:cTn id="13" presetID="1" presetClass="entr" presetSubtype="0" fill="hold" grpId="0" nodeType="clickEffect">
+                                  <p:stCondLst>
+                                    <p:cond delay="0"/>
+                                  </p:stCondLst>
+                                  <p:childTnLst>
+                                    <p:set>
+                                      <p:cBhvr>
+                                        <p:cTn id="14" dur="1" fill="hold">
+                                          <p:stCondLst>
+                                            <p:cond delay="0"/>
+                                          </p:stCondLst>
+                                        </p:cTn>
+                                        <p:tgtEl>
+                                          <p:spTgt spid="5"/>
+                                        </p:tgtEl>
+                                        <p:attrNameLst>
+                                          <p:attrName>style.visibility</p:attrName>
+                                        </p:attrNameLst>
+                                      </p:cBhvr>
+                                      <p:to>
+                                        <p:strVal val="visible"/>
+                                      </p:to>
+                                    </p:set>
+                                  </p:childTnLst>
+                                </p:cTn>
+                              </p:par>
+                            </p:childTnLst>
+                          </p:cTn>
+                        </p:par>
+                      </p:childTnLst>
+                    </p:cTn>
+                  </p:par>
                 </p:childTnLst>
               </p:cTn>
               <p:prevCondLst>
@@ -15609,6 +15699,8 @@
     </p:tnLst>
     <p:bldLst>
       <p:bldP spid="3" grpId="0" animBg="1"/>
+      <p:bldP spid="4" grpId="0" animBg="1"/>
+      <p:bldP spid="5" grpId="0" animBg="1"/>
     </p:bldLst>
   </p:timing>
 </p:sld>
@@ -16145,7 +16237,7 @@
             <a:fld id="{DD253308-F9C5-4FCB-8415-6DEE77C16A35}" type="slidenum">
               <a:rPr lang="en-US" smtClean="0"/>
               <a:pPr/>
-              <a:t>10</a:t>
+              <a:t>6</a:t>
             </a:fld>
             <a:endParaRPr lang="en-US" dirty="0"/>
           </a:p>
@@ -16453,7 +16545,7 @@
             <a:fld id="{DD253308-F9C5-4FCB-8415-6DEE77C16A35}" type="slidenum">
               <a:rPr lang="en-US" smtClean="0"/>
               <a:pPr/>
-              <a:t>10</a:t>
+              <a:t>7</a:t>
             </a:fld>
             <a:endParaRPr lang="en-US" dirty="0"/>
           </a:p>
@@ -16671,7 +16763,7 @@
             <a:fld id="{DD253308-F9C5-4FCB-8415-6DEE77C16A35}" type="slidenum">
               <a:rPr lang="en-US" smtClean="0"/>
               <a:pPr/>
-              <a:t>10</a:t>
+              <a:t>8</a:t>
             </a:fld>
             <a:endParaRPr lang="en-US" dirty="0"/>
           </a:p>
@@ -17482,7 +17574,7 @@
             <a:fld id="{DD253308-F9C5-4FCB-8415-6DEE77C16A35}" type="slidenum">
               <a:rPr lang="en-US" smtClean="0"/>
               <a:pPr/>
-              <a:t>10</a:t>
+              <a:t>9</a:t>
             </a:fld>
             <a:endParaRPr lang="en-US" dirty="0"/>
           </a:p>

</xml_diff>

<commit_message>
Polish v9: slide 27 reconciled story (priors + RQ1 null)
Reverts the v8 attribution figure and restores the prior_distributions
visual Jose liked, but adds an RQ1-null reconciliation in bullet 1: the
priors don't bite at the first wager (label anchoring), they bite at
integration (likelihood weighting on the outcome).

Bullet language preserves Jose's voice from v7b: "cluster high +
narrow", "spread wide", "praised or penalized", "telegraph their
standards", "top 10%", and the "stronger confidence cells"
parenthetical.

Subtitle: "Same starting wager, different weight on the outcome."
Figure:   prior_distributions.png (back from v6/v7b)
Caption:  Hypothesized prior distributions

Co-Authored-By: Claude Opus 4.6 (1M context) <noreply@anthropic.com>
</commit_message>
<xml_diff>
--- a/docs/UChicago-0410.pptx
+++ b/docs/UChicago-0410.pptx
@@ -22810,7 +22810,7 @@
                 </a:solidFill>
                 <a:latin typeface="Arial"/>
               </a:rPr>
-              <a:t>Different attributions of the same outcome.</a:t>
+              <a:t>Same starting wager, different weight on the outcome.</a:t>
             </a:r>
           </a:p>
         </p:txBody>
@@ -22885,7 +22885,7 @@
                 </a:solidFill>
                 <a:latin typeface="Arial"/>
               </a:rPr>
-              <a:t>Same starting point for men and women.</a:t>
+              <a:t>People hold different priors for men vs women.</a:t>
             </a:r>
           </a:p>
           <a:p>
@@ -22901,7 +22901,7 @@
                 </a:solidFill>
                 <a:latin typeface="Arial"/>
               </a:rPr>
-              <a:t>Initial wagers are identical by gender (b = -1.06, p = .81). Evaluators take the endorsement at face value before any outcome.</a:t>
+              <a:t>Men are assumed critical; women are assumed nicer on average. But the priors don't bite at the first wager (b = -1.06, p = .81), because evaluators anchor automatically on the strength label.</a:t>
             </a:r>
           </a:p>
         </p:txBody>
@@ -22976,7 +22976,7 @@
                 </a:solidFill>
                 <a:latin typeface="Arial"/>
               </a:rPr>
-              <a:t>But outcomes get attributed differently.</a:t>
+              <a:t>Women's endorsements cluster high + narrow.</a:t>
             </a:r>
           </a:p>
           <a:p>
@@ -22992,7 +22992,7 @@
                 </a:solidFill>
                 <a:latin typeface="Arial"/>
               </a:rPr>
-              <a:t>A man's correct call reads as "his judgment"; his wrong call reads as "his bad call." Either way, reputation moves.</a:t>
+              <a:t>"She would have said it either way" makes her outcome barely informative, so evaluators discount the update (consistent with the muted effects in the stronger confidence cells).</a:t>
             </a:r>
           </a:p>
         </p:txBody>
@@ -23067,7 +23067,7 @@
                 </a:solidFill>
                 <a:latin typeface="Arial"/>
               </a:rPr>
-              <a:t>Women's outcomes get read as luck or situation.</a:t>
+              <a:t>Men's endorsements spread wide.</a:t>
             </a:r>
           </a:p>
           <a:p>
@@ -23083,7 +23083,7 @@
                 </a:solidFill>
                 <a:latin typeface="Arial"/>
               </a:rPr>
-              <a:t>"She got the easy one" or "bad luck on that one." The outcome barely updates trust in her judgment.</a:t>
+              <a:t>When men endorse with confidence it carries information that can be both praised or penalized, and the outcome moves trust accordingly.</a:t>
             </a:r>
           </a:p>
         </p:txBody>
@@ -23158,7 +23158,7 @@
                 </a:solidFill>
                 <a:latin typeface="Arial"/>
               </a:rPr>
-              <a:t>Next direction: telegraph selectivity.</a:t>
+              <a:t>Next direction: telegraph their standards.</a:t>
             </a:r>
           </a:p>
           <a:p>
@@ -23174,21 +23174,21 @@
                 </a:solidFill>
                 <a:latin typeface="Arial"/>
               </a:rPr>
-              <a:t>Does "I only recommend the top 10%" force her outcome to be re-attributed to her judgment?</a:t>
+              <a:t>Signaling "I only recommend the top 10%" breaks the assumed clustering, so the outcome can be re-read as informative.</a:t>
             </a:r>
           </a:p>
         </p:txBody>
       </p:sp>
       <p:pic>
         <p:nvPicPr>
-          <p:cNvPr id="227" name="Picture 226" descr="attribution_theory.png"/>
+          <p:cNvPr id="227" name="Picture 226" descr="image.png"/>
           <p:cNvPicPr>
             <a:picLocks noChangeAspect="1"/>
           </p:cNvPicPr>
           <p:nvPr/>
         </p:nvPicPr>
         <p:blipFill>
-          <a:blip r:embed="rId4"/>
+          <a:blip r:embed="rId3"/>
           <a:stretch>
             <a:fillRect/>
           </a:stretch>
@@ -23233,7 +23233,7 @@
                 </a:solidFill>
                 <a:latin typeface="Arial"/>
               </a:rPr>
-              <a:t>Hypothesized attribution weights</a:t>
+              <a:t>Hypothesized prior distributions</a:t>
             </a:r>
           </a:p>
         </p:txBody>

</xml_diff>

<commit_message>
Polish v10: slide 27 bullet 1 reframed as rational reserve
Refines v9. Bullets 2/3/4 and the prior_distributions figure are
unchanged. Bullet 1 is rewritten to Jose's sharper intuition: RQ1 is
null not because evaluators are taking a cognitive shortcut at the
first wager, but because there's literally no information yet to
discriminate on, so being reserved is rational. The outcome is the
first piece of information that lets latent priors actually bite.

Bullet 1 also flags the contrast with the standard discrimination
literature ("Unlike most discrimination findings, the gap leaks in
only at the outcome") so the theoretical contribution lives on the
slide.

Subtitle: "The prior leaks in once there's an outcome to read."
B1 hdr:   "Without a track record, people stay reserved."

Co-Authored-By: Claude Opus 4.6 (1M context) <noreply@anthropic.com>
</commit_message>
<xml_diff>
--- a/docs/UChicago-0410.pptx
+++ b/docs/UChicago-0410.pptx
@@ -22810,7 +22810,7 @@
                 </a:solidFill>
                 <a:latin typeface="Arial"/>
               </a:rPr>
-              <a:t>Same starting wager, different weight on the outcome.</a:t>
+              <a:t>The prior leaks in once there's an outcome to read.</a:t>
             </a:r>
           </a:p>
         </p:txBody>
@@ -22885,7 +22885,7 @@
                 </a:solidFill>
                 <a:latin typeface="Arial"/>
               </a:rPr>
-              <a:t>People hold different priors for men vs women.</a:t>
+              <a:t>Without a track record, people stay reserved.</a:t>
             </a:r>
           </a:p>
           <a:p>
@@ -22901,7 +22901,7 @@
                 </a:solidFill>
                 <a:latin typeface="Arial"/>
               </a:rPr>
-              <a:t>Men are assumed critical; women are assumed nicer on average. But the priors don't bite at the first wager (b = -1.06, p = .81), because evaluators anchor automatically on the strength label.</a:t>
+              <a:t>RQ1 is null (b = -1.06, p = .81). With nothing but a strength label, there's no basis to discriminate yet. Unlike most discrimination findings, the gap leaks in only at the outcome.</a:t>
             </a:r>
           </a:p>
         </p:txBody>
@@ -22992,7 +22992,7 @@
                 </a:solidFill>
                 <a:latin typeface="Arial"/>
               </a:rPr>
-              <a:t>"She would have said it either way" makes her outcome barely informative, so evaluators discount the update (consistent with the muted effects in the stronger confidence cells).</a:t>
+              <a:t>Once the outcome arrives, "she would have said it either way" makes it barely informative, so trust barely moves (consistent with the muted effects in the stronger confidence cells).</a:t>
             </a:r>
           </a:p>
         </p:txBody>

</xml_diff>

<commit_message>
Polish v11: slide 27 perception-vs-fact tweak
Adds "are assumed" to bullet 2/3 headers so they read as evaluator
beliefs about endorsements, not factual claims about the actual
distributions. Important because Jose has separate evidence that
men's and women's actual endorsement strengths don't differ — the
gendered prior is in evaluators' heads, not in the data.

B2 hdr: "Women's endorsements are assumed high + narrow."
B3 hdr: "Men's endorsements are assumed to spread wide."
B3 body: "Evaluators read men's confident calls as carrying
         information that can be both praised or penalized..."
         (was "When men endorse with confidence it carries
         information..." which sounded factual)

Bullets 1, 4, subtitle, figure, and caption unchanged.

Co-Authored-By: Claude Opus 4.6 (1M context) <noreply@anthropic.com>
</commit_message>
<xml_diff>
--- a/docs/UChicago-0410.pptx
+++ b/docs/UChicago-0410.pptx
@@ -22976,7 +22976,7 @@
                 </a:solidFill>
                 <a:latin typeface="Arial"/>
               </a:rPr>
-              <a:t>Women's endorsements cluster high + narrow.</a:t>
+              <a:t>Women's endorsements are assumed high + narrow.</a:t>
             </a:r>
           </a:p>
           <a:p>
@@ -23067,7 +23067,7 @@
                 </a:solidFill>
                 <a:latin typeface="Arial"/>
               </a:rPr>
-              <a:t>Men's endorsements spread wide.</a:t>
+              <a:t>Men's endorsements are assumed to spread wide.</a:t>
             </a:r>
           </a:p>
           <a:p>
@@ -23083,7 +23083,7 @@
                 </a:solidFill>
                 <a:latin typeface="Arial"/>
               </a:rPr>
-              <a:t>When men endorse with confidence it carries information that can be both praised or penalized, and the outcome moves trust accordingly.</a:t>
+              <a:t>Evaluators read men's confident calls as carrying information that can be both praised or penalized, so trust moves accordingly.</a:t>
             </a:r>
           </a:p>
         </p:txBody>

</xml_diff>